<commit_message>
Update Notebook and Readme
</commit_message>
<xml_diff>
--- a/presentation.pptx
+++ b/presentation.pptx
@@ -112,6 +112,35 @@
     </a:lvl9pPr>
   </p:defaultTextStyle>
 </p:presentation>
+</file>
+
+<file path=ppt/changesInfos/changesInfo1.xml><?xml version="1.0" encoding="utf-8"?>
+<pc:chgInfo xmlns:a="http://schemas.openxmlformats.org/drawingml/2006/main" xmlns:r="http://schemas.openxmlformats.org/officeDocument/2006/relationships" xmlns:ac="http://schemas.microsoft.com/office/drawing/2013/main/command" xmlns:pc="http://schemas.microsoft.com/office/powerpoint/2013/main/command">
+  <pc:docChgLst>
+    <pc:chgData name="Keith Njihia" userId="1e99fe23f231bfb1" providerId="LiveId" clId="{3A04604A-EEBB-4A6F-99F6-790ED387411E}"/>
+    <pc:docChg chg="custSel modSld">
+      <pc:chgData name="Keith Njihia" userId="1e99fe23f231bfb1" providerId="LiveId" clId="{3A04604A-EEBB-4A6F-99F6-790ED387411E}" dt="2026-06-12T16:10:07.546" v="10" actId="27636"/>
+      <pc:docMkLst>
+        <pc:docMk/>
+      </pc:docMkLst>
+      <pc:sldChg chg="modSp mod">
+        <pc:chgData name="Keith Njihia" userId="1e99fe23f231bfb1" providerId="LiveId" clId="{3A04604A-EEBB-4A6F-99F6-790ED387411E}" dt="2026-06-12T16:10:07.546" v="10" actId="27636"/>
+        <pc:sldMkLst>
+          <pc:docMk/>
+          <pc:sldMk cId="3839852327" sldId="261"/>
+        </pc:sldMkLst>
+        <pc:spChg chg="mod">
+          <ac:chgData name="Keith Njihia" userId="1e99fe23f231bfb1" providerId="LiveId" clId="{3A04604A-EEBB-4A6F-99F6-790ED387411E}" dt="2026-06-12T16:10:07.546" v="10" actId="27636"/>
+          <ac:spMkLst>
+            <pc:docMk/>
+            <pc:sldMk cId="3839852327" sldId="261"/>
+            <ac:spMk id="3" creationId="{1BDA4AD8-17F4-D33B-5D75-8BA6E8F62357}"/>
+          </ac:spMkLst>
+        </pc:spChg>
+      </pc:sldChg>
+    </pc:docChg>
+  </pc:docChgLst>
+</pc:chgInfo>
 </file>
 
 <file path=ppt/slideLayouts/slideLayout1.xml><?xml version="1.0" encoding="utf-8"?>
@@ -6165,7 +6194,7 @@
         </p:spPr>
         <p:txBody>
           <a:bodyPr anchor="t">
-            <a:normAutofit/>
+            <a:normAutofit lnSpcReduction="10000"/>
           </a:bodyPr>
           <a:lstStyle/>
           <a:p>
@@ -6271,6 +6300,19 @@
                 </a:solidFill>
               </a:rPr>
               <a:t>Random Forest          | [67.5%]</a:t>
+            </a:r>
+          </a:p>
+          <a:p>
+            <a:pPr marL="0" indent="0">
+              <a:buNone/>
+            </a:pPr>
+            <a:r>
+              <a:rPr lang="en-US" sz="2000" dirty="0">
+                <a:solidFill>
+                  <a:schemeClr val="bg1"/>
+                </a:solidFill>
+              </a:rPr>
+              <a:t>Pipeline (LR)  | 69.07%</a:t>
             </a:r>
           </a:p>
         </p:txBody>

</xml_diff>